<commit_message>
oss and bigdata midtest
</commit_message>
<xml_diff>
--- a/오픈소스소프트웨어/2주차_OSS_라이선스.pptx
+++ b/오픈소스소프트웨어/2주차_OSS_라이선스.pptx
@@ -2039,6 +2039,13 @@
           </a:solidFill>
           <a:ln/>
         </p:spPr>
+        <p:txBody>
+          <a:bodyPr/>
+          <a:lstStyle/>
+          <a:p>
+            <a:endParaRPr lang="ko-KR" altLang="en-US"/>
+          </a:p>
+        </p:txBody>
       </p:sp>
       <p:sp>
         <p:nvSpPr>
@@ -2328,6 +2335,13 @@
           </a:solidFill>
           <a:ln/>
         </p:spPr>
+        <p:txBody>
+          <a:bodyPr/>
+          <a:lstStyle/>
+          <a:p>
+            <a:endParaRPr lang="ko-KR" altLang="en-US"/>
+          </a:p>
+        </p:txBody>
       </p:sp>
       <p:sp>
         <p:nvSpPr>
@@ -2467,6 +2481,13 @@
           </a:solidFill>
           <a:ln/>
         </p:spPr>
+        <p:txBody>
+          <a:bodyPr/>
+          <a:lstStyle/>
+          <a:p>
+            <a:endParaRPr lang="ko-KR" altLang="en-US"/>
+          </a:p>
+        </p:txBody>
       </p:sp>
       <p:sp>
         <p:nvSpPr>
@@ -2567,6 +2588,13 @@
           </a:solidFill>
           <a:ln/>
         </p:spPr>
+        <p:txBody>
+          <a:bodyPr/>
+          <a:lstStyle/>
+          <a:p>
+            <a:endParaRPr lang="ko-KR" altLang="en-US"/>
+          </a:p>
+        </p:txBody>
       </p:sp>
       <p:sp>
         <p:nvSpPr>
@@ -3106,6 +3134,13 @@
           </a:solidFill>
           <a:ln/>
         </p:spPr>
+        <p:txBody>
+          <a:bodyPr/>
+          <a:lstStyle/>
+          <a:p>
+            <a:endParaRPr lang="ko-KR" altLang="en-US"/>
+          </a:p>
+        </p:txBody>
       </p:sp>
       <p:sp>
         <p:nvSpPr>
@@ -3245,6 +3280,13 @@
           </a:solidFill>
           <a:ln/>
         </p:spPr>
+        <p:txBody>
+          <a:bodyPr/>
+          <a:lstStyle/>
+          <a:p>
+            <a:endParaRPr lang="ko-KR" altLang="en-US"/>
+          </a:p>
+        </p:txBody>
       </p:sp>
       <p:sp>
         <p:nvSpPr>
@@ -3385,7 +3427,7 @@
               <a:t> </a:t>
             </a:r>
             <a:r>
-              <a:rPr lang="en-US" sz="1100" dirty="0" err="1" smtClean="0">
+              <a:rPr lang="en-US" sz="1100" dirty="0" err="1">
                 <a:solidFill>
                   <a:srgbClr val="1C1633"/>
                 </a:solidFill>
@@ -3396,7 +3438,7 @@
               <a:t>라이선스</a:t>
             </a:r>
             <a:r>
-              <a:rPr lang="en-US" sz="1100" dirty="0" smtClean="0">
+              <a:rPr lang="en-US" sz="1100" dirty="0">
                 <a:solidFill>
                   <a:srgbClr val="1C1633"/>
                 </a:solidFill>
@@ -3404,18 +3446,7 @@
                 <a:ea typeface="맑은 고딕" pitchFamily="34" charset="-122"/>
                 <a:cs typeface="맑은 고딕" pitchFamily="34" charset="-120"/>
               </a:rPr>
-              <a:t>(</a:t>
-            </a:r>
-            <a:r>
-              <a:rPr lang="en-US" sz="1100" dirty="0">
-                <a:solidFill>
-                  <a:srgbClr val="1C1633"/>
-                </a:solidFill>
-                <a:latin typeface="맑은 고딕" pitchFamily="34" charset="0"/>
-                <a:ea typeface="맑은 고딕" pitchFamily="34" charset="-122"/>
-                <a:cs typeface="맑은 고딕" pitchFamily="34" charset="-120"/>
-              </a:rPr>
-              <a:t>미국 정부 재원으로 개발)</a:t>
+              <a:t>(미국 정부 재원으로 개발)</a:t>
             </a:r>
             <a:endParaRPr lang="en-US" sz="1100" dirty="0"/>
           </a:p>
@@ -3526,6 +3557,13 @@
           </a:solidFill>
           <a:ln/>
         </p:spPr>
+        <p:txBody>
+          <a:bodyPr/>
+          <a:lstStyle/>
+          <a:p>
+            <a:endParaRPr lang="ko-KR" altLang="en-US"/>
+          </a:p>
+        </p:txBody>
       </p:sp>
       <p:sp>
         <p:nvSpPr>
@@ -3902,6 +3940,13 @@
           </a:solidFill>
           <a:ln/>
         </p:spPr>
+        <p:txBody>
+          <a:bodyPr/>
+          <a:lstStyle/>
+          <a:p>
+            <a:endParaRPr lang="ko-KR" altLang="en-US"/>
+          </a:p>
+        </p:txBody>
       </p:sp>
       <p:sp>
         <p:nvSpPr>
@@ -4039,7 +4084,7 @@
               <a:t> </a:t>
             </a:r>
             <a:r>
-              <a:rPr lang="en-US" sz="1350" dirty="0" err="1" smtClean="0">
+              <a:rPr lang="en-US" sz="1350" dirty="0" err="1">
                 <a:solidFill>
                   <a:srgbClr val="6E6690"/>
                 </a:solidFill>
@@ -4050,7 +4095,7 @@
               <a:t>요구되는가</a:t>
             </a:r>
             <a:r>
-              <a:rPr lang="en-US" sz="1350" dirty="0" smtClean="0">
+              <a:rPr lang="en-US" sz="1350" dirty="0">
                 <a:solidFill>
                   <a:srgbClr val="6E6690"/>
                 </a:solidFill>
@@ -4088,6 +4133,13 @@
             <a:prstDash val="solid"/>
           </a:ln>
         </p:spPr>
+        <p:txBody>
+          <a:bodyPr/>
+          <a:lstStyle/>
+          <a:p>
+            <a:endParaRPr lang="ko-KR" altLang="en-US"/>
+          </a:p>
+        </p:txBody>
       </p:sp>
       <p:sp>
         <p:nvSpPr>
@@ -4152,6 +4204,13 @@
             <a:prstDash val="solid"/>
           </a:ln>
         </p:spPr>
+        <p:txBody>
+          <a:bodyPr/>
+          <a:lstStyle/>
+          <a:p>
+            <a:endParaRPr lang="ko-KR" altLang="en-US"/>
+          </a:p>
+        </p:txBody>
       </p:sp>
       <p:sp>
         <p:nvSpPr>
@@ -4216,6 +4275,13 @@
             <a:prstDash val="solid"/>
           </a:ln>
         </p:spPr>
+        <p:txBody>
+          <a:bodyPr/>
+          <a:lstStyle/>
+          <a:p>
+            <a:endParaRPr lang="ko-KR" altLang="en-US"/>
+          </a:p>
+        </p:txBody>
       </p:sp>
       <p:sp>
         <p:nvSpPr>
@@ -4280,6 +4346,13 @@
             <a:prstDash val="solid"/>
           </a:ln>
         </p:spPr>
+        <p:txBody>
+          <a:bodyPr/>
+          <a:lstStyle/>
+          <a:p>
+            <a:endParaRPr lang="ko-KR" altLang="en-US"/>
+          </a:p>
+        </p:txBody>
       </p:sp>
       <p:sp>
         <p:nvSpPr>
@@ -4344,6 +4417,13 @@
             <a:prstDash val="solid"/>
           </a:ln>
         </p:spPr>
+        <p:txBody>
+          <a:bodyPr/>
+          <a:lstStyle/>
+          <a:p>
+            <a:endParaRPr lang="ko-KR" altLang="en-US"/>
+          </a:p>
+        </p:txBody>
       </p:sp>
       <p:sp>
         <p:nvSpPr>
@@ -4408,6 +4488,13 @@
             <a:prstDash val="solid"/>
           </a:ln>
         </p:spPr>
+        <p:txBody>
+          <a:bodyPr/>
+          <a:lstStyle/>
+          <a:p>
+            <a:endParaRPr lang="ko-KR" altLang="en-US"/>
+          </a:p>
+        </p:txBody>
       </p:sp>
       <p:sp>
         <p:nvSpPr>
@@ -4472,6 +4559,13 @@
             <a:prstDash val="solid"/>
           </a:ln>
         </p:spPr>
+        <p:txBody>
+          <a:bodyPr/>
+          <a:lstStyle/>
+          <a:p>
+            <a:endParaRPr lang="ko-KR" altLang="en-US"/>
+          </a:p>
+        </p:txBody>
       </p:sp>
       <p:sp>
         <p:nvSpPr>
@@ -4536,6 +4630,13 @@
             <a:prstDash val="solid"/>
           </a:ln>
         </p:spPr>
+        <p:txBody>
+          <a:bodyPr/>
+          <a:lstStyle/>
+          <a:p>
+            <a:endParaRPr lang="ko-KR" altLang="en-US"/>
+          </a:p>
+        </p:txBody>
       </p:sp>
       <p:sp>
         <p:nvSpPr>
@@ -4600,6 +4701,13 @@
             <a:prstDash val="solid"/>
           </a:ln>
         </p:spPr>
+        <p:txBody>
+          <a:bodyPr/>
+          <a:lstStyle/>
+          <a:p>
+            <a:endParaRPr lang="ko-KR" altLang="en-US"/>
+          </a:p>
+        </p:txBody>
       </p:sp>
       <p:sp>
         <p:nvSpPr>
@@ -4664,6 +4772,13 @@
             <a:prstDash val="solid"/>
           </a:ln>
         </p:spPr>
+        <p:txBody>
+          <a:bodyPr/>
+          <a:lstStyle/>
+          <a:p>
+            <a:endParaRPr lang="ko-KR" altLang="en-US"/>
+          </a:p>
+        </p:txBody>
       </p:sp>
       <p:sp>
         <p:nvSpPr>
@@ -4728,6 +4843,13 @@
             <a:prstDash val="solid"/>
           </a:ln>
         </p:spPr>
+        <p:txBody>
+          <a:bodyPr/>
+          <a:lstStyle/>
+          <a:p>
+            <a:endParaRPr lang="ko-KR" altLang="en-US"/>
+          </a:p>
+        </p:txBody>
       </p:sp>
       <p:sp>
         <p:nvSpPr>
@@ -4792,6 +4914,13 @@
             <a:prstDash val="solid"/>
           </a:ln>
         </p:spPr>
+        <p:txBody>
+          <a:bodyPr/>
+          <a:lstStyle/>
+          <a:p>
+            <a:endParaRPr lang="ko-KR" altLang="en-US"/>
+          </a:p>
+        </p:txBody>
       </p:sp>
       <p:sp>
         <p:nvSpPr>
@@ -4856,6 +4985,13 @@
             <a:prstDash val="solid"/>
           </a:ln>
         </p:spPr>
+        <p:txBody>
+          <a:bodyPr/>
+          <a:lstStyle/>
+          <a:p>
+            <a:endParaRPr lang="ko-KR" altLang="en-US"/>
+          </a:p>
+        </p:txBody>
       </p:sp>
       <p:sp>
         <p:nvSpPr>
@@ -4920,6 +5056,13 @@
             <a:prstDash val="solid"/>
           </a:ln>
         </p:spPr>
+        <p:txBody>
+          <a:bodyPr/>
+          <a:lstStyle/>
+          <a:p>
+            <a:endParaRPr lang="ko-KR" altLang="en-US"/>
+          </a:p>
+        </p:txBody>
       </p:sp>
       <p:sp>
         <p:nvSpPr>
@@ -4984,6 +5127,13 @@
             <a:prstDash val="solid"/>
           </a:ln>
         </p:spPr>
+        <p:txBody>
+          <a:bodyPr/>
+          <a:lstStyle/>
+          <a:p>
+            <a:endParaRPr lang="ko-KR" altLang="en-US"/>
+          </a:p>
+        </p:txBody>
       </p:sp>
       <p:sp>
         <p:nvSpPr>
@@ -5048,6 +5198,13 @@
             <a:prstDash val="solid"/>
           </a:ln>
         </p:spPr>
+        <p:txBody>
+          <a:bodyPr/>
+          <a:lstStyle/>
+          <a:p>
+            <a:endParaRPr lang="ko-KR" altLang="en-US"/>
+          </a:p>
+        </p:txBody>
       </p:sp>
       <p:sp>
         <p:nvSpPr>
@@ -5112,6 +5269,13 @@
             <a:prstDash val="solid"/>
           </a:ln>
         </p:spPr>
+        <p:txBody>
+          <a:bodyPr/>
+          <a:lstStyle/>
+          <a:p>
+            <a:endParaRPr lang="ko-KR" altLang="en-US"/>
+          </a:p>
+        </p:txBody>
       </p:sp>
       <p:sp>
         <p:nvSpPr>
@@ -5176,6 +5340,13 @@
             <a:prstDash val="solid"/>
           </a:ln>
         </p:spPr>
+        <p:txBody>
+          <a:bodyPr/>
+          <a:lstStyle/>
+          <a:p>
+            <a:endParaRPr lang="ko-KR" altLang="en-US"/>
+          </a:p>
+        </p:txBody>
       </p:sp>
       <p:sp>
         <p:nvSpPr>
@@ -5240,6 +5411,13 @@
             <a:prstDash val="solid"/>
           </a:ln>
         </p:spPr>
+        <p:txBody>
+          <a:bodyPr/>
+          <a:lstStyle/>
+          <a:p>
+            <a:endParaRPr lang="ko-KR" altLang="en-US"/>
+          </a:p>
+        </p:txBody>
       </p:sp>
       <p:sp>
         <p:nvSpPr>
@@ -5304,6 +5482,13 @@
             <a:prstDash val="solid"/>
           </a:ln>
         </p:spPr>
+        <p:txBody>
+          <a:bodyPr/>
+          <a:lstStyle/>
+          <a:p>
+            <a:endParaRPr lang="ko-KR" altLang="en-US"/>
+          </a:p>
+        </p:txBody>
       </p:sp>
       <p:sp>
         <p:nvSpPr>
@@ -5368,6 +5553,13 @@
             <a:prstDash val="solid"/>
           </a:ln>
         </p:spPr>
+        <p:txBody>
+          <a:bodyPr/>
+          <a:lstStyle/>
+          <a:p>
+            <a:endParaRPr lang="ko-KR" altLang="en-US"/>
+          </a:p>
+        </p:txBody>
       </p:sp>
       <p:sp>
         <p:nvSpPr>
@@ -5432,6 +5624,13 @@
             <a:prstDash val="solid"/>
           </a:ln>
         </p:spPr>
+        <p:txBody>
+          <a:bodyPr/>
+          <a:lstStyle/>
+          <a:p>
+            <a:endParaRPr lang="ko-KR" altLang="en-US"/>
+          </a:p>
+        </p:txBody>
       </p:sp>
       <p:sp>
         <p:nvSpPr>
@@ -5496,6 +5695,13 @@
             <a:prstDash val="solid"/>
           </a:ln>
         </p:spPr>
+        <p:txBody>
+          <a:bodyPr/>
+          <a:lstStyle/>
+          <a:p>
+            <a:endParaRPr lang="ko-KR" altLang="en-US"/>
+          </a:p>
+        </p:txBody>
       </p:sp>
       <p:sp>
         <p:nvSpPr>
@@ -5560,6 +5766,13 @@
             <a:prstDash val="solid"/>
           </a:ln>
         </p:spPr>
+        <p:txBody>
+          <a:bodyPr/>
+          <a:lstStyle/>
+          <a:p>
+            <a:endParaRPr lang="ko-KR" altLang="en-US"/>
+          </a:p>
+        </p:txBody>
       </p:sp>
       <p:sp>
         <p:nvSpPr>
@@ -5624,6 +5837,13 @@
             <a:prstDash val="solid"/>
           </a:ln>
         </p:spPr>
+        <p:txBody>
+          <a:bodyPr/>
+          <a:lstStyle/>
+          <a:p>
+            <a:endParaRPr lang="ko-KR" altLang="en-US"/>
+          </a:p>
+        </p:txBody>
       </p:sp>
       <p:sp>
         <p:nvSpPr>
@@ -5688,6 +5908,13 @@
             <a:prstDash val="solid"/>
           </a:ln>
         </p:spPr>
+        <p:txBody>
+          <a:bodyPr/>
+          <a:lstStyle/>
+          <a:p>
+            <a:endParaRPr lang="ko-KR" altLang="en-US"/>
+          </a:p>
+        </p:txBody>
       </p:sp>
       <p:sp>
         <p:nvSpPr>
@@ -5752,6 +5979,13 @@
             <a:prstDash val="solid"/>
           </a:ln>
         </p:spPr>
+        <p:txBody>
+          <a:bodyPr/>
+          <a:lstStyle/>
+          <a:p>
+            <a:endParaRPr lang="ko-KR" altLang="en-US"/>
+          </a:p>
+        </p:txBody>
       </p:sp>
       <p:sp>
         <p:nvSpPr>
@@ -5816,6 +6050,13 @@
             <a:prstDash val="solid"/>
           </a:ln>
         </p:spPr>
+        <p:txBody>
+          <a:bodyPr/>
+          <a:lstStyle/>
+          <a:p>
+            <a:endParaRPr lang="ko-KR" altLang="en-US"/>
+          </a:p>
+        </p:txBody>
       </p:sp>
       <p:sp>
         <p:nvSpPr>
@@ -5880,6 +6121,13 @@
             <a:prstDash val="solid"/>
           </a:ln>
         </p:spPr>
+        <p:txBody>
+          <a:bodyPr/>
+          <a:lstStyle/>
+          <a:p>
+            <a:endParaRPr lang="ko-KR" altLang="en-US"/>
+          </a:p>
+        </p:txBody>
       </p:sp>
       <p:sp>
         <p:nvSpPr>
@@ -5944,6 +6192,13 @@
             <a:prstDash val="solid"/>
           </a:ln>
         </p:spPr>
+        <p:txBody>
+          <a:bodyPr/>
+          <a:lstStyle/>
+          <a:p>
+            <a:endParaRPr lang="ko-KR" altLang="en-US"/>
+          </a:p>
+        </p:txBody>
       </p:sp>
       <p:sp>
         <p:nvSpPr>
@@ -6008,6 +6263,13 @@
             <a:prstDash val="solid"/>
           </a:ln>
         </p:spPr>
+        <p:txBody>
+          <a:bodyPr/>
+          <a:lstStyle/>
+          <a:p>
+            <a:endParaRPr lang="ko-KR" altLang="en-US"/>
+          </a:p>
+        </p:txBody>
       </p:sp>
       <p:sp>
         <p:nvSpPr>
@@ -6072,6 +6334,13 @@
             <a:prstDash val="solid"/>
           </a:ln>
         </p:spPr>
+        <p:txBody>
+          <a:bodyPr/>
+          <a:lstStyle/>
+          <a:p>
+            <a:endParaRPr lang="ko-KR" altLang="en-US"/>
+          </a:p>
+        </p:txBody>
       </p:sp>
       <p:sp>
         <p:nvSpPr>
@@ -6136,6 +6405,13 @@
             <a:prstDash val="solid"/>
           </a:ln>
         </p:spPr>
+        <p:txBody>
+          <a:bodyPr/>
+          <a:lstStyle/>
+          <a:p>
+            <a:endParaRPr lang="ko-KR" altLang="en-US"/>
+          </a:p>
+        </p:txBody>
       </p:sp>
       <p:sp>
         <p:nvSpPr>
@@ -6200,6 +6476,13 @@
             <a:prstDash val="solid"/>
           </a:ln>
         </p:spPr>
+        <p:txBody>
+          <a:bodyPr/>
+          <a:lstStyle/>
+          <a:p>
+            <a:endParaRPr lang="ko-KR" altLang="en-US"/>
+          </a:p>
+        </p:txBody>
       </p:sp>
       <p:sp>
         <p:nvSpPr>
@@ -6264,6 +6547,13 @@
             <a:prstDash val="solid"/>
           </a:ln>
         </p:spPr>
+        <p:txBody>
+          <a:bodyPr/>
+          <a:lstStyle/>
+          <a:p>
+            <a:endParaRPr lang="ko-KR" altLang="en-US"/>
+          </a:p>
+        </p:txBody>
       </p:sp>
       <p:sp>
         <p:nvSpPr>
@@ -6328,6 +6618,13 @@
             <a:prstDash val="solid"/>
           </a:ln>
         </p:spPr>
+        <p:txBody>
+          <a:bodyPr/>
+          <a:lstStyle/>
+          <a:p>
+            <a:endParaRPr lang="ko-KR" altLang="en-US"/>
+          </a:p>
+        </p:txBody>
       </p:sp>
       <p:sp>
         <p:nvSpPr>
@@ -6392,6 +6689,13 @@
             <a:prstDash val="solid"/>
           </a:ln>
         </p:spPr>
+        <p:txBody>
+          <a:bodyPr/>
+          <a:lstStyle/>
+          <a:p>
+            <a:endParaRPr lang="ko-KR" altLang="en-US"/>
+          </a:p>
+        </p:txBody>
       </p:sp>
       <p:sp>
         <p:nvSpPr>
@@ -6456,6 +6760,13 @@
             <a:prstDash val="solid"/>
           </a:ln>
         </p:spPr>
+        <p:txBody>
+          <a:bodyPr/>
+          <a:lstStyle/>
+          <a:p>
+            <a:endParaRPr lang="ko-KR" altLang="en-US"/>
+          </a:p>
+        </p:txBody>
       </p:sp>
       <p:sp>
         <p:nvSpPr>
@@ -6520,6 +6831,13 @@
             <a:prstDash val="solid"/>
           </a:ln>
         </p:spPr>
+        <p:txBody>
+          <a:bodyPr/>
+          <a:lstStyle/>
+          <a:p>
+            <a:endParaRPr lang="ko-KR" altLang="en-US"/>
+          </a:p>
+        </p:txBody>
       </p:sp>
       <p:sp>
         <p:nvSpPr>
@@ -6584,6 +6902,13 @@
             <a:prstDash val="solid"/>
           </a:ln>
         </p:spPr>
+        <p:txBody>
+          <a:bodyPr/>
+          <a:lstStyle/>
+          <a:p>
+            <a:endParaRPr lang="ko-KR" altLang="en-US"/>
+          </a:p>
+        </p:txBody>
       </p:sp>
       <p:sp>
         <p:nvSpPr>
@@ -6648,6 +6973,13 @@
             <a:prstDash val="solid"/>
           </a:ln>
         </p:spPr>
+        <p:txBody>
+          <a:bodyPr/>
+          <a:lstStyle/>
+          <a:p>
+            <a:endParaRPr lang="ko-KR" altLang="en-US"/>
+          </a:p>
+        </p:txBody>
       </p:sp>
       <p:sp>
         <p:nvSpPr>
@@ -6712,6 +7044,13 @@
             <a:prstDash val="solid"/>
           </a:ln>
         </p:spPr>
+        <p:txBody>
+          <a:bodyPr/>
+          <a:lstStyle/>
+          <a:p>
+            <a:endParaRPr lang="ko-KR" altLang="en-US"/>
+          </a:p>
+        </p:txBody>
       </p:sp>
       <p:sp>
         <p:nvSpPr>
@@ -6776,6 +7115,13 @@
             <a:prstDash val="solid"/>
           </a:ln>
         </p:spPr>
+        <p:txBody>
+          <a:bodyPr/>
+          <a:lstStyle/>
+          <a:p>
+            <a:endParaRPr lang="ko-KR" altLang="en-US"/>
+          </a:p>
+        </p:txBody>
       </p:sp>
       <p:sp>
         <p:nvSpPr>
@@ -6840,6 +7186,13 @@
             <a:prstDash val="solid"/>
           </a:ln>
         </p:spPr>
+        <p:txBody>
+          <a:bodyPr/>
+          <a:lstStyle/>
+          <a:p>
+            <a:endParaRPr lang="ko-KR" altLang="en-US"/>
+          </a:p>
+        </p:txBody>
       </p:sp>
       <p:sp>
         <p:nvSpPr>
@@ -6904,6 +7257,13 @@
             <a:prstDash val="solid"/>
           </a:ln>
         </p:spPr>
+        <p:txBody>
+          <a:bodyPr/>
+          <a:lstStyle/>
+          <a:p>
+            <a:endParaRPr lang="ko-KR" altLang="en-US"/>
+          </a:p>
+        </p:txBody>
       </p:sp>
       <p:sp>
         <p:nvSpPr>
@@ -6968,6 +7328,13 @@
             <a:prstDash val="solid"/>
           </a:ln>
         </p:spPr>
+        <p:txBody>
+          <a:bodyPr/>
+          <a:lstStyle/>
+          <a:p>
+            <a:endParaRPr lang="ko-KR" altLang="en-US"/>
+          </a:p>
+        </p:txBody>
       </p:sp>
       <p:sp>
         <p:nvSpPr>
@@ -7032,6 +7399,13 @@
             <a:prstDash val="solid"/>
           </a:ln>
         </p:spPr>
+        <p:txBody>
+          <a:bodyPr/>
+          <a:lstStyle/>
+          <a:p>
+            <a:endParaRPr lang="ko-KR" altLang="en-US"/>
+          </a:p>
+        </p:txBody>
       </p:sp>
       <p:sp>
         <p:nvSpPr>
@@ -7096,6 +7470,13 @@
             <a:prstDash val="solid"/>
           </a:ln>
         </p:spPr>
+        <p:txBody>
+          <a:bodyPr/>
+          <a:lstStyle/>
+          <a:p>
+            <a:endParaRPr lang="ko-KR" altLang="en-US"/>
+          </a:p>
+        </p:txBody>
       </p:sp>
       <p:sp>
         <p:nvSpPr>
@@ -7175,7 +7556,7 @@
               <a:t>△ 특허 조항은 버전에 따라 다릅니다 — GPLv2·LGPLv2.1은 명시적 특허 조항이 없고, GPLv3·LGPLv3부터 </a:t>
             </a:r>
             <a:r>
-              <a:rPr lang="en-US" sz="1000" i="1" dirty="0" err="1" smtClean="0">
+              <a:rPr lang="en-US" sz="1000" i="1" dirty="0" err="1">
                 <a:solidFill>
                   <a:srgbClr val="6E6690"/>
                 </a:solidFill>
@@ -7186,7 +7567,7 @@
               <a:t>추가되었습니다</a:t>
             </a:r>
             <a:r>
-              <a:rPr lang="en-US" sz="1000" i="1" dirty="0" smtClean="0">
+              <a:rPr lang="en-US" sz="1000" i="1" dirty="0">
                 <a:solidFill>
                   <a:srgbClr val="6E6690"/>
                 </a:solidFill>
@@ -7205,7 +7586,7 @@
               <a:buNone/>
             </a:pPr>
             <a:r>
-              <a:rPr lang="en-US" sz="1000" i="1" dirty="0" smtClean="0">
+              <a:rPr lang="en-US" sz="1000" i="1" dirty="0">
                 <a:solidFill>
                   <a:srgbClr val="6E6690"/>
                 </a:solidFill>
@@ -7213,18 +7594,7 @@
                 <a:ea typeface="맑은 고딕" pitchFamily="34" charset="-122"/>
                 <a:cs typeface="맑은 고딕" pitchFamily="34" charset="-120"/>
               </a:rPr>
-              <a:t> </a:t>
-            </a:r>
-            <a:r>
-              <a:rPr lang="en-US" sz="1000" i="1" dirty="0">
-                <a:solidFill>
-                  <a:srgbClr val="6E6690"/>
-                </a:solidFill>
-                <a:latin typeface="맑은 고딕" pitchFamily="34" charset="0"/>
-                <a:ea typeface="맑은 고딕" pitchFamily="34" charset="-122"/>
-                <a:cs typeface="맑은 고딕" pitchFamily="34" charset="-120"/>
-              </a:rPr>
-              <a:t>2차 저작물 공개 의무가 있는 GPL만 독점(폐쇄형) SW와의 결합이 불가능합니다.</a:t>
+              <a:t> 2차 저작물 공개 의무가 있는 GPL만 독점(폐쇄형) SW와의 결합이 불가능합니다.</a:t>
             </a:r>
             <a:endParaRPr lang="en-US" sz="1000" dirty="0"/>
           </a:p>
@@ -7359,6 +7729,13 @@
           </a:solidFill>
           <a:ln/>
         </p:spPr>
+        <p:txBody>
+          <a:bodyPr/>
+          <a:lstStyle/>
+          <a:p>
+            <a:endParaRPr lang="ko-KR" altLang="en-US"/>
+          </a:p>
+        </p:txBody>
       </p:sp>
       <p:sp>
         <p:nvSpPr>
@@ -7498,6 +7875,13 @@
           </a:solidFill>
           <a:ln/>
         </p:spPr>
+        <p:txBody>
+          <a:bodyPr/>
+          <a:lstStyle/>
+          <a:p>
+            <a:endParaRPr lang="ko-KR" altLang="en-US"/>
+          </a:p>
+        </p:txBody>
       </p:sp>
       <p:sp>
         <p:nvSpPr>
@@ -7601,6 +7985,13 @@
           </a:solidFill>
           <a:ln/>
         </p:spPr>
+        <p:txBody>
+          <a:bodyPr/>
+          <a:lstStyle/>
+          <a:p>
+            <a:endParaRPr lang="ko-KR" altLang="en-US"/>
+          </a:p>
+        </p:txBody>
       </p:sp>
       <p:sp>
         <p:nvSpPr>
@@ -7704,6 +8095,13 @@
           </a:solidFill>
           <a:ln/>
         </p:spPr>
+        <p:txBody>
+          <a:bodyPr/>
+          <a:lstStyle/>
+          <a:p>
+            <a:endParaRPr lang="ko-KR" altLang="en-US"/>
+          </a:p>
+        </p:txBody>
       </p:sp>
       <p:sp>
         <p:nvSpPr>
@@ -7765,6 +8163,13 @@
           </a:solidFill>
           <a:ln/>
         </p:spPr>
+        <p:txBody>
+          <a:bodyPr/>
+          <a:lstStyle/>
+          <a:p>
+            <a:endParaRPr lang="ko-KR" altLang="en-US"/>
+          </a:p>
+        </p:txBody>
       </p:sp>
       <p:sp>
         <p:nvSpPr>
@@ -7865,6 +8270,13 @@
           </a:solidFill>
           <a:ln/>
         </p:spPr>
+        <p:txBody>
+          <a:bodyPr/>
+          <a:lstStyle/>
+          <a:p>
+            <a:endParaRPr lang="ko-KR" altLang="en-US"/>
+          </a:p>
+        </p:txBody>
       </p:sp>
       <p:sp>
         <p:nvSpPr>
@@ -7965,6 +8377,13 @@
           </a:solidFill>
           <a:ln/>
         </p:spPr>
+        <p:txBody>
+          <a:bodyPr/>
+          <a:lstStyle/>
+          <a:p>
+            <a:endParaRPr lang="ko-KR" altLang="en-US"/>
+          </a:p>
+        </p:txBody>
       </p:sp>
       <p:sp>
         <p:nvSpPr>
@@ -8129,6 +8548,13 @@
           </a:solidFill>
           <a:ln/>
         </p:spPr>
+        <p:txBody>
+          <a:bodyPr/>
+          <a:lstStyle/>
+          <a:p>
+            <a:endParaRPr lang="ko-KR" altLang="en-US"/>
+          </a:p>
+        </p:txBody>
       </p:sp>
       <p:sp>
         <p:nvSpPr>
@@ -8232,6 +8658,13 @@
           </a:solidFill>
           <a:ln/>
         </p:spPr>
+        <p:txBody>
+          <a:bodyPr/>
+          <a:lstStyle/>
+          <a:p>
+            <a:endParaRPr lang="ko-KR" altLang="en-US"/>
+          </a:p>
+        </p:txBody>
       </p:sp>
       <p:sp>
         <p:nvSpPr>
@@ -8493,6 +8926,13 @@
           </a:solidFill>
           <a:ln/>
         </p:spPr>
+        <p:txBody>
+          <a:bodyPr/>
+          <a:lstStyle/>
+          <a:p>
+            <a:endParaRPr lang="ko-KR" altLang="en-US"/>
+          </a:p>
+        </p:txBody>
       </p:sp>
       <p:sp>
         <p:nvSpPr>
@@ -8632,6 +9072,13 @@
           </a:solidFill>
           <a:ln/>
         </p:spPr>
+        <p:txBody>
+          <a:bodyPr/>
+          <a:lstStyle/>
+          <a:p>
+            <a:endParaRPr lang="ko-KR" altLang="en-US"/>
+          </a:p>
+        </p:txBody>
       </p:sp>
       <p:sp>
         <p:nvSpPr>
@@ -8735,6 +9182,13 @@
           </a:solidFill>
           <a:ln/>
         </p:spPr>
+        <p:txBody>
+          <a:bodyPr/>
+          <a:lstStyle/>
+          <a:p>
+            <a:endParaRPr lang="ko-KR" altLang="en-US"/>
+          </a:p>
+        </p:txBody>
       </p:sp>
       <p:sp>
         <p:nvSpPr>
@@ -8859,6 +9313,13 @@
           </a:solidFill>
           <a:ln/>
         </p:spPr>
+        <p:txBody>
+          <a:bodyPr/>
+          <a:lstStyle/>
+          <a:p>
+            <a:endParaRPr lang="ko-KR" altLang="en-US"/>
+          </a:p>
+        </p:txBody>
       </p:sp>
       <p:sp>
         <p:nvSpPr>
@@ -8962,6 +9423,13 @@
           </a:solidFill>
           <a:ln/>
         </p:spPr>
+        <p:txBody>
+          <a:bodyPr/>
+          <a:lstStyle/>
+          <a:p>
+            <a:endParaRPr lang="ko-KR" altLang="en-US"/>
+          </a:p>
+        </p:txBody>
       </p:sp>
       <p:sp>
         <p:nvSpPr>
@@ -9149,6 +9617,13 @@
           </a:solidFill>
           <a:ln/>
         </p:spPr>
+        <p:txBody>
+          <a:bodyPr/>
+          <a:lstStyle/>
+          <a:p>
+            <a:endParaRPr lang="ko-KR" altLang="en-US"/>
+          </a:p>
+        </p:txBody>
       </p:sp>
       <p:sp>
         <p:nvSpPr>
@@ -9288,6 +9763,13 @@
           </a:solidFill>
           <a:ln/>
         </p:spPr>
+        <p:txBody>
+          <a:bodyPr/>
+          <a:lstStyle/>
+          <a:p>
+            <a:endParaRPr lang="ko-KR" altLang="en-US"/>
+          </a:p>
+        </p:txBody>
       </p:sp>
       <p:sp>
         <p:nvSpPr>
@@ -9430,6 +9912,13 @@
           </a:solidFill>
           <a:ln/>
         </p:spPr>
+        <p:txBody>
+          <a:bodyPr/>
+          <a:lstStyle/>
+          <a:p>
+            <a:endParaRPr lang="ko-KR" altLang="en-US"/>
+          </a:p>
+        </p:txBody>
       </p:sp>
       <p:sp>
         <p:nvSpPr>
@@ -9572,6 +10061,13 @@
           </a:solidFill>
           <a:ln/>
         </p:spPr>
+        <p:txBody>
+          <a:bodyPr/>
+          <a:lstStyle/>
+          <a:p>
+            <a:endParaRPr lang="ko-KR" altLang="en-US"/>
+          </a:p>
+        </p:txBody>
       </p:sp>
       <p:sp>
         <p:nvSpPr>
@@ -9714,6 +10210,13 @@
           </a:solidFill>
           <a:ln/>
         </p:spPr>
+        <p:txBody>
+          <a:bodyPr/>
+          <a:lstStyle/>
+          <a:p>
+            <a:endParaRPr lang="ko-KR" altLang="en-US"/>
+          </a:p>
+        </p:txBody>
       </p:sp>
       <p:sp>
         <p:nvSpPr>
@@ -9856,6 +10359,13 @@
           </a:solidFill>
           <a:ln/>
         </p:spPr>
+        <p:txBody>
+          <a:bodyPr/>
+          <a:lstStyle/>
+          <a:p>
+            <a:endParaRPr lang="ko-KR" altLang="en-US"/>
+          </a:p>
+        </p:txBody>
       </p:sp>
       <p:sp>
         <p:nvSpPr>
@@ -10070,6 +10580,13 @@
           </a:solidFill>
           <a:ln/>
         </p:spPr>
+        <p:txBody>
+          <a:bodyPr/>
+          <a:lstStyle/>
+          <a:p>
+            <a:endParaRPr lang="ko-KR" altLang="en-US"/>
+          </a:p>
+        </p:txBody>
       </p:sp>
       <p:sp>
         <p:nvSpPr>
@@ -10209,6 +10726,13 @@
           </a:solidFill>
           <a:ln/>
         </p:spPr>
+        <p:txBody>
+          <a:bodyPr/>
+          <a:lstStyle/>
+          <a:p>
+            <a:endParaRPr lang="ko-KR" altLang="en-US"/>
+          </a:p>
+        </p:txBody>
       </p:sp>
       <p:sp>
         <p:nvSpPr>
@@ -10315,6 +10839,13 @@
           </a:solidFill>
           <a:ln/>
         </p:spPr>
+        <p:txBody>
+          <a:bodyPr/>
+          <a:lstStyle/>
+          <a:p>
+            <a:endParaRPr lang="ko-KR" altLang="en-US"/>
+          </a:p>
+        </p:txBody>
       </p:sp>
       <p:sp>
         <p:nvSpPr>
@@ -10421,6 +10952,13 @@
           </a:solidFill>
           <a:ln/>
         </p:spPr>
+        <p:txBody>
+          <a:bodyPr/>
+          <a:lstStyle/>
+          <a:p>
+            <a:endParaRPr lang="ko-KR" altLang="en-US"/>
+          </a:p>
+        </p:txBody>
       </p:sp>
       <p:sp>
         <p:nvSpPr>
@@ -10527,6 +11065,13 @@
           </a:solidFill>
           <a:ln/>
         </p:spPr>
+        <p:txBody>
+          <a:bodyPr/>
+          <a:lstStyle/>
+          <a:p>
+            <a:endParaRPr lang="ko-KR" altLang="en-US"/>
+          </a:p>
+        </p:txBody>
       </p:sp>
       <p:sp>
         <p:nvSpPr>
@@ -10845,6 +11390,13 @@
           </a:solidFill>
           <a:ln/>
         </p:spPr>
+        <p:txBody>
+          <a:bodyPr/>
+          <a:lstStyle/>
+          <a:p>
+            <a:endParaRPr lang="ko-KR" altLang="en-US"/>
+          </a:p>
+        </p:txBody>
       </p:sp>
       <p:sp>
         <p:nvSpPr>
@@ -11249,6 +11801,13 @@
           </a:solidFill>
           <a:ln/>
         </p:spPr>
+        <p:txBody>
+          <a:bodyPr/>
+          <a:lstStyle/>
+          <a:p>
+            <a:endParaRPr lang="ko-KR" altLang="en-US"/>
+          </a:p>
+        </p:txBody>
       </p:sp>
       <p:sp>
         <p:nvSpPr>
@@ -11389,6 +11948,13 @@
             <a:prstDash val="solid"/>
           </a:ln>
         </p:spPr>
+        <p:txBody>
+          <a:bodyPr/>
+          <a:lstStyle/>
+          <a:p>
+            <a:endParaRPr lang="ko-KR" altLang="en-US"/>
+          </a:p>
+        </p:txBody>
       </p:sp>
       <p:sp>
         <p:nvSpPr>
@@ -11409,6 +11975,13 @@
           </a:solidFill>
           <a:ln/>
         </p:spPr>
+        <p:txBody>
+          <a:bodyPr/>
+          <a:lstStyle/>
+          <a:p>
+            <a:endParaRPr lang="ko-KR" altLang="en-US"/>
+          </a:p>
+        </p:txBody>
       </p:sp>
       <p:sp>
         <p:nvSpPr>
@@ -11549,6 +12122,13 @@
             <a:prstDash val="solid"/>
           </a:ln>
         </p:spPr>
+        <p:txBody>
+          <a:bodyPr/>
+          <a:lstStyle/>
+          <a:p>
+            <a:endParaRPr lang="ko-KR" altLang="en-US"/>
+          </a:p>
+        </p:txBody>
       </p:sp>
       <p:sp>
         <p:nvSpPr>
@@ -11569,6 +12149,13 @@
           </a:solidFill>
           <a:ln/>
         </p:spPr>
+        <p:txBody>
+          <a:bodyPr/>
+          <a:lstStyle/>
+          <a:p>
+            <a:endParaRPr lang="ko-KR" altLang="en-US"/>
+          </a:p>
+        </p:txBody>
       </p:sp>
       <p:sp>
         <p:nvSpPr>
@@ -11709,6 +12296,13 @@
             <a:prstDash val="solid"/>
           </a:ln>
         </p:spPr>
+        <p:txBody>
+          <a:bodyPr/>
+          <a:lstStyle/>
+          <a:p>
+            <a:endParaRPr lang="ko-KR" altLang="en-US"/>
+          </a:p>
+        </p:txBody>
       </p:sp>
       <p:sp>
         <p:nvSpPr>
@@ -11729,6 +12323,13 @@
           </a:solidFill>
           <a:ln/>
         </p:spPr>
+        <p:txBody>
+          <a:bodyPr/>
+          <a:lstStyle/>
+          <a:p>
+            <a:endParaRPr lang="ko-KR" altLang="en-US"/>
+          </a:p>
+        </p:txBody>
       </p:sp>
       <p:sp>
         <p:nvSpPr>
@@ -11869,6 +12470,13 @@
             <a:prstDash val="solid"/>
           </a:ln>
         </p:spPr>
+        <p:txBody>
+          <a:bodyPr/>
+          <a:lstStyle/>
+          <a:p>
+            <a:endParaRPr lang="ko-KR" altLang="en-US"/>
+          </a:p>
+        </p:txBody>
       </p:sp>
       <p:sp>
         <p:nvSpPr>
@@ -11889,6 +12497,13 @@
           </a:solidFill>
           <a:ln/>
         </p:spPr>
+        <p:txBody>
+          <a:bodyPr/>
+          <a:lstStyle/>
+          <a:p>
+            <a:endParaRPr lang="ko-KR" altLang="en-US"/>
+          </a:p>
+        </p:txBody>
       </p:sp>
       <p:sp>
         <p:nvSpPr>
@@ -12139,6 +12754,13 @@
           </a:solidFill>
           <a:ln/>
         </p:spPr>
+        <p:txBody>
+          <a:bodyPr/>
+          <a:lstStyle/>
+          <a:p>
+            <a:endParaRPr lang="ko-KR" altLang="en-US"/>
+          </a:p>
+        </p:txBody>
       </p:sp>
       <p:sp>
         <p:nvSpPr>
@@ -12278,6 +12900,13 @@
           </a:solidFill>
           <a:ln/>
         </p:spPr>
+        <p:txBody>
+          <a:bodyPr/>
+          <a:lstStyle/>
+          <a:p>
+            <a:endParaRPr lang="ko-KR" altLang="en-US"/>
+          </a:p>
+        </p:txBody>
       </p:sp>
       <p:sp>
         <p:nvSpPr>
@@ -12356,14 +12985,6 @@
               </a:rPr>
               <a:t>창작과 동시에 자동으로 발생하는 권리. </a:t>
             </a:r>
-            <a:endParaRPr lang="en-US" sz="1100" dirty="0" smtClean="0">
-              <a:solidFill>
-                <a:srgbClr val="1C1633"/>
-              </a:solidFill>
-              <a:latin typeface="맑은 고딕" pitchFamily="34" charset="0"/>
-              <a:ea typeface="맑은 고딕" pitchFamily="34" charset="-122"/>
-              <a:cs typeface="맑은 고딕" pitchFamily="34" charset="-120"/>
-            </a:endParaRPr>
           </a:p>
           <a:p>
             <a:pPr marL="0" indent="0">
@@ -12373,7 +12994,7 @@
               <a:buNone/>
             </a:pPr>
             <a:r>
-              <a:rPr lang="en-US" sz="1100" dirty="0" err="1" smtClean="0">
+              <a:rPr lang="en-US" sz="1100" dirty="0" err="1">
                 <a:solidFill>
                   <a:srgbClr val="1C1633"/>
                 </a:solidFill>
@@ -12384,7 +13005,7 @@
               <a:t>저작물을</a:t>
             </a:r>
             <a:r>
-              <a:rPr lang="en-US" sz="1100" dirty="0" smtClean="0">
+              <a:rPr lang="en-US" sz="1100" dirty="0">
                 <a:solidFill>
                   <a:srgbClr val="1C1633"/>
                 </a:solidFill>
@@ -12392,18 +13013,7 @@
                 <a:ea typeface="맑은 고딕" pitchFamily="34" charset="-122"/>
                 <a:cs typeface="맑은 고딕" pitchFamily="34" charset="-120"/>
               </a:rPr>
-              <a:t> </a:t>
-            </a:r>
-            <a:r>
-              <a:rPr lang="en-US" sz="1100" dirty="0">
-                <a:solidFill>
-                  <a:srgbClr val="1C1633"/>
-                </a:solidFill>
-                <a:latin typeface="맑은 고딕" pitchFamily="34" charset="0"/>
-                <a:ea typeface="맑은 고딕" pitchFamily="34" charset="-122"/>
-                <a:cs typeface="맑은 고딕" pitchFamily="34" charset="-120"/>
-              </a:rPr>
-              <a:t>보호하고, 타인이 쓰려면 저작자의 허락이 필요.</a:t>
+              <a:t> 보호하고, 타인이 쓰려면 저작자의 허락이 필요.</a:t>
             </a:r>
             <a:endParaRPr lang="en-US" sz="1100" dirty="0"/>
           </a:p>
@@ -12430,6 +13040,13 @@
           </a:solidFill>
           <a:ln/>
         </p:spPr>
+        <p:txBody>
+          <a:bodyPr/>
+          <a:lstStyle/>
+          <a:p>
+            <a:endParaRPr lang="ko-KR" altLang="en-US"/>
+          </a:p>
+        </p:txBody>
       </p:sp>
       <p:sp>
         <p:nvSpPr>
@@ -12533,6 +13150,13 @@
           </a:solidFill>
           <a:ln/>
         </p:spPr>
+        <p:txBody>
+          <a:bodyPr/>
+          <a:lstStyle/>
+          <a:p>
+            <a:endParaRPr lang="ko-KR" altLang="en-US"/>
+          </a:p>
+        </p:txBody>
       </p:sp>
       <p:sp>
         <p:nvSpPr>
@@ -12611,14 +13235,6 @@
               </a:rPr>
               <a:t>저작권자가 사용자에게 내리는 '사용 허가'. </a:t>
             </a:r>
-            <a:endParaRPr lang="en-US" sz="1100" dirty="0" smtClean="0">
-              <a:solidFill>
-                <a:srgbClr val="1C1633"/>
-              </a:solidFill>
-              <a:latin typeface="맑은 고딕" pitchFamily="34" charset="0"/>
-              <a:ea typeface="맑은 고딕" pitchFamily="34" charset="-122"/>
-              <a:cs typeface="맑은 고딕" pitchFamily="34" charset="-120"/>
-            </a:endParaRPr>
           </a:p>
           <a:p>
             <a:pPr marL="0" indent="0">
@@ -12628,7 +13244,7 @@
               <a:buNone/>
             </a:pPr>
             <a:r>
-              <a:rPr lang="en-US" sz="1100" dirty="0" err="1" smtClean="0">
+              <a:rPr lang="en-US" sz="1100" dirty="0" err="1">
                 <a:solidFill>
                   <a:srgbClr val="1C1633"/>
                 </a:solidFill>
@@ -12639,7 +13255,7 @@
               <a:t>정해진</a:t>
             </a:r>
             <a:r>
-              <a:rPr lang="en-US" sz="1100" dirty="0" smtClean="0">
+              <a:rPr lang="en-US" sz="1100" dirty="0">
                 <a:solidFill>
                   <a:srgbClr val="1C1633"/>
                 </a:solidFill>
@@ -12647,9 +13263,42 @@
                 <a:ea typeface="맑은 고딕" pitchFamily="34" charset="-122"/>
                 <a:cs typeface="맑은 고딕" pitchFamily="34" charset="-120"/>
               </a:rPr>
+              <a:t> 조건 아래 </a:t>
+            </a:r>
+            <a:r>
+              <a:rPr lang="en-US" sz="1100" dirty="0" err="1">
+                <a:solidFill>
+                  <a:srgbClr val="1C1633"/>
+                </a:solidFill>
+                <a:latin typeface="맑은 고딕" pitchFamily="34" charset="0"/>
+                <a:ea typeface="맑은 고딕" pitchFamily="34" charset="-122"/>
+                <a:cs typeface="맑은 고딕" pitchFamily="34" charset="-120"/>
+              </a:rPr>
+              <a:t>사용·수정·배포의</a:t>
+            </a:r>
+            <a:r>
+              <a:rPr lang="en-US" sz="1100" dirty="0">
+                <a:solidFill>
+                  <a:srgbClr val="1C1633"/>
+                </a:solidFill>
+                <a:latin typeface="맑은 고딕" pitchFamily="34" charset="0"/>
+                <a:ea typeface="맑은 고딕" pitchFamily="34" charset="-122"/>
+                <a:cs typeface="맑은 고딕" pitchFamily="34" charset="-120"/>
+              </a:rPr>
               <a:t> </a:t>
             </a:r>
             <a:r>
+              <a:rPr lang="en-US" sz="1100" dirty="0" err="1">
+                <a:solidFill>
+                  <a:srgbClr val="1C1633"/>
+                </a:solidFill>
+                <a:latin typeface="맑은 고딕" pitchFamily="34" charset="0"/>
+                <a:ea typeface="맑은 고딕" pitchFamily="34" charset="-122"/>
+                <a:cs typeface="맑은 고딕" pitchFamily="34" charset="-120"/>
+              </a:rPr>
+              <a:t>자유</a:t>
+            </a:r>
+            <a:r>
               <a:rPr lang="en-US" sz="1100" dirty="0">
                 <a:solidFill>
                   <a:srgbClr val="1C1633"/>
@@ -12658,84 +13307,7 @@
                 <a:ea typeface="맑은 고딕" pitchFamily="34" charset="-122"/>
                 <a:cs typeface="맑은 고딕" pitchFamily="34" charset="-120"/>
               </a:rPr>
-              <a:t>조건 아래 </a:t>
-            </a:r>
-            <a:r>
-              <a:rPr lang="en-US" sz="1100" dirty="0" err="1">
-                <a:solidFill>
-                  <a:srgbClr val="1C1633"/>
-                </a:solidFill>
-                <a:latin typeface="맑은 고딕" pitchFamily="34" charset="0"/>
-                <a:ea typeface="맑은 고딕" pitchFamily="34" charset="-122"/>
-                <a:cs typeface="맑은 고딕" pitchFamily="34" charset="-120"/>
-              </a:rPr>
-              <a:t>사용</a:t>
-            </a:r>
-            <a:r>
-              <a:rPr lang="en-US" sz="1100" dirty="0" err="1" smtClean="0">
-                <a:solidFill>
-                  <a:srgbClr val="1C1633"/>
-                </a:solidFill>
-                <a:latin typeface="맑은 고딕" pitchFamily="34" charset="0"/>
-                <a:ea typeface="맑은 고딕" pitchFamily="34" charset="-122"/>
-                <a:cs typeface="맑은 고딕" pitchFamily="34" charset="-120"/>
-              </a:rPr>
-              <a:t>·수정</a:t>
-            </a:r>
-            <a:r>
-              <a:rPr lang="en-US" sz="1100" dirty="0" err="1">
-                <a:solidFill>
-                  <a:srgbClr val="1C1633"/>
-                </a:solidFill>
-                <a:latin typeface="맑은 고딕" pitchFamily="34" charset="0"/>
-                <a:ea typeface="맑은 고딕" pitchFamily="34" charset="-122"/>
-                <a:cs typeface="맑은 고딕" pitchFamily="34" charset="-120"/>
-              </a:rPr>
-              <a:t>·배포의</a:t>
-            </a:r>
-            <a:r>
-              <a:rPr lang="en-US" sz="1100" dirty="0">
-                <a:solidFill>
-                  <a:srgbClr val="1C1633"/>
-                </a:solidFill>
-                <a:latin typeface="맑은 고딕" pitchFamily="34" charset="0"/>
-                <a:ea typeface="맑은 고딕" pitchFamily="34" charset="-122"/>
-                <a:cs typeface="맑은 고딕" pitchFamily="34" charset="-120"/>
-              </a:rPr>
-              <a:t> </a:t>
-            </a:r>
-            <a:r>
-              <a:rPr lang="en-US" sz="1100" dirty="0" err="1" smtClean="0">
-                <a:solidFill>
-                  <a:srgbClr val="1C1633"/>
-                </a:solidFill>
-                <a:latin typeface="맑은 고딕" pitchFamily="34" charset="0"/>
-                <a:ea typeface="맑은 고딕" pitchFamily="34" charset="-122"/>
-                <a:cs typeface="맑은 고딕" pitchFamily="34" charset="-120"/>
-              </a:rPr>
-              <a:t>자유</a:t>
-            </a:r>
-            <a:r>
-              <a:rPr lang="en-US" sz="1100" dirty="0" smtClean="0">
-                <a:solidFill>
-                  <a:srgbClr val="1C1633"/>
-                </a:solidFill>
-                <a:latin typeface="맑은 고딕" pitchFamily="34" charset="0"/>
-                <a:ea typeface="맑은 고딕" pitchFamily="34" charset="-122"/>
-                <a:cs typeface="맑은 고딕" pitchFamily="34" charset="-120"/>
-              </a:rPr>
-              <a:t> </a:t>
-            </a:r>
-            <a:r>
-              <a:rPr lang="en-US" sz="1100" dirty="0">
-                <a:solidFill>
-                  <a:srgbClr val="1C1633"/>
-                </a:solidFill>
-                <a:latin typeface="맑은 고딕" pitchFamily="34" charset="0"/>
-                <a:ea typeface="맑은 고딕" pitchFamily="34" charset="-122"/>
-                <a:cs typeface="맑은 고딕" pitchFamily="34" charset="-120"/>
-              </a:rPr>
-              <a:t>허용.</a:t>
+              <a:t> 허용.</a:t>
             </a:r>
             <a:endParaRPr lang="en-US" sz="1100" dirty="0"/>
           </a:p>
@@ -12762,6 +13334,13 @@
           </a:solidFill>
           <a:ln/>
         </p:spPr>
+        <p:txBody>
+          <a:bodyPr/>
+          <a:lstStyle/>
+          <a:p>
+            <a:endParaRPr lang="ko-KR" altLang="en-US"/>
+          </a:p>
+        </p:txBody>
       </p:sp>
       <p:sp>
         <p:nvSpPr>
@@ -12784,6 +13363,13 @@
           </a:solidFill>
           <a:ln/>
         </p:spPr>
+        <p:txBody>
+          <a:bodyPr/>
+          <a:lstStyle/>
+          <a:p>
+            <a:endParaRPr lang="ko-KR" altLang="en-US"/>
+          </a:p>
+        </p:txBody>
       </p:sp>
       <p:sp>
         <p:nvSpPr>
@@ -12868,6 +13454,13 @@
           </a:solidFill>
           <a:ln/>
         </p:spPr>
+        <p:txBody>
+          <a:bodyPr/>
+          <a:lstStyle/>
+          <a:p>
+            <a:endParaRPr lang="ko-KR" altLang="en-US"/>
+          </a:p>
+        </p:txBody>
       </p:sp>
       <p:sp>
         <p:nvSpPr>
@@ -12954,6 +13547,13 @@
             <a:tailEnd type="triangle"/>
           </a:ln>
         </p:spPr>
+        <p:txBody>
+          <a:bodyPr/>
+          <a:lstStyle/>
+          <a:p>
+            <a:endParaRPr lang="ko-KR" altLang="en-US"/>
+          </a:p>
+        </p:txBody>
       </p:sp>
       <p:sp>
         <p:nvSpPr>
@@ -12988,29 +13588,7 @@
                 <a:ea typeface="맑은 고딕" pitchFamily="34" charset="-122"/>
                 <a:cs typeface="맑은 고딕" pitchFamily="34" charset="-120"/>
               </a:rPr>
-              <a:t>사용 · </a:t>
-            </a:r>
-            <a:r>
-              <a:rPr lang="en-US" sz="1000" b="1" dirty="0" smtClean="0">
-                <a:solidFill>
-                  <a:srgbClr val="4C2FB0"/>
-                </a:solidFill>
-                <a:latin typeface="맑은 고딕" pitchFamily="34" charset="0"/>
-                <a:ea typeface="맑은 고딕" pitchFamily="34" charset="-122"/>
-                <a:cs typeface="맑은 고딕" pitchFamily="34" charset="-120"/>
-              </a:rPr>
-              <a:t> </a:t>
-            </a:r>
-            <a:r>
-              <a:rPr lang="en-US" sz="1000" b="1" dirty="0">
-                <a:solidFill>
-                  <a:srgbClr val="4C2FB0"/>
-                </a:solidFill>
-                <a:latin typeface="맑은 고딕" pitchFamily="34" charset="0"/>
-                <a:ea typeface="맑은 고딕" pitchFamily="34" charset="-122"/>
-                <a:cs typeface="맑은 고딕" pitchFamily="34" charset="-120"/>
-              </a:rPr>
-              <a:t>수정 · 배포의 자유</a:t>
+              <a:t>사용 ·  수정 · 배포의 자유</a:t>
             </a:r>
             <a:endParaRPr lang="en-US" sz="1000" dirty="0"/>
           </a:p>
@@ -13039,6 +13617,13 @@
             <a:headEnd type="triangle"/>
           </a:ln>
         </p:spPr>
+        <p:txBody>
+          <a:bodyPr/>
+          <a:lstStyle/>
+          <a:p>
+            <a:endParaRPr lang="ko-KR" altLang="en-US"/>
+          </a:p>
+        </p:txBody>
       </p:sp>
       <p:sp>
         <p:nvSpPr>
@@ -13250,6 +13835,13 @@
           </a:solidFill>
           <a:ln/>
         </p:spPr>
+        <p:txBody>
+          <a:bodyPr/>
+          <a:lstStyle/>
+          <a:p>
+            <a:endParaRPr lang="ko-KR" altLang="en-US"/>
+          </a:p>
+        </p:txBody>
       </p:sp>
       <p:sp>
         <p:nvSpPr>
@@ -13389,6 +13981,13 @@
           </a:solidFill>
           <a:ln/>
         </p:spPr>
+        <p:txBody>
+          <a:bodyPr/>
+          <a:lstStyle/>
+          <a:p>
+            <a:endParaRPr lang="ko-KR" altLang="en-US"/>
+          </a:p>
+        </p:txBody>
       </p:sp>
       <p:sp>
         <p:nvSpPr>
@@ -13467,14 +14066,6 @@
               </a:rPr>
               <a:t>전체 오픈소스 컴포넌트 중 </a:t>
             </a:r>
-            <a:endParaRPr lang="en-US" sz="1100" dirty="0" smtClean="0">
-              <a:solidFill>
-                <a:srgbClr val="1C1633"/>
-              </a:solidFill>
-              <a:latin typeface="맑은 고딕" pitchFamily="34" charset="0"/>
-              <a:ea typeface="맑은 고딕" pitchFamily="34" charset="-122"/>
-              <a:cs typeface="맑은 고딕" pitchFamily="34" charset="-120"/>
-            </a:endParaRPr>
           </a:p>
           <a:p>
             <a:pPr marL="0" indent="0">
@@ -13484,7 +14075,7 @@
               <a:buNone/>
             </a:pPr>
             <a:r>
-              <a:rPr lang="en-US" sz="1100" dirty="0" smtClean="0">
+              <a:rPr lang="en-US" sz="1100" dirty="0">
                 <a:solidFill>
                   <a:srgbClr val="1C1633"/>
                 </a:solidFill>
@@ -13492,18 +14083,7 @@
                 <a:ea typeface="맑은 고딕" pitchFamily="34" charset="-122"/>
                 <a:cs typeface="맑은 고딕" pitchFamily="34" charset="-120"/>
               </a:rPr>
-              <a:t>Permissive </a:t>
-            </a:r>
-            <a:r>
-              <a:rPr lang="en-US" sz="1100" dirty="0">
-                <a:solidFill>
-                  <a:srgbClr val="1C1633"/>
-                </a:solidFill>
-                <a:latin typeface="맑은 고딕" pitchFamily="34" charset="0"/>
-                <a:ea typeface="맑은 고딕" pitchFamily="34" charset="-122"/>
-                <a:cs typeface="맑은 고딕" pitchFamily="34" charset="-120"/>
-              </a:rPr>
-              <a:t>라이선스 비중 (2024년)</a:t>
+              <a:t>Permissive 라이선스 비중 (2024년)</a:t>
             </a:r>
             <a:endParaRPr lang="en-US" sz="1100" dirty="0"/>
           </a:p>
@@ -13530,6 +14110,13 @@
           </a:solidFill>
           <a:ln/>
         </p:spPr>
+        <p:txBody>
+          <a:bodyPr/>
+          <a:lstStyle/>
+          <a:p>
+            <a:endParaRPr lang="ko-KR" altLang="en-US"/>
+          </a:p>
+        </p:txBody>
       </p:sp>
       <p:sp>
         <p:nvSpPr>
@@ -13604,7 +14191,7 @@
               <a:rPr lang="ko-KR" altLang="en-US" sz="1100" dirty="0"/>
               <a:t>라이선스 코드를 포함한 </a:t>
             </a:r>
-            <a:endParaRPr lang="en-US" altLang="ko-KR" sz="1100" dirty="0" smtClean="0"/>
+            <a:endParaRPr lang="en-US" altLang="ko-KR" sz="1100" dirty="0"/>
           </a:p>
           <a:p>
             <a:pPr>
@@ -13613,12 +14200,8 @@
               </a:lnSpc>
             </a:pPr>
             <a:r>
-              <a:rPr lang="ko-KR" altLang="en-US" sz="1100" dirty="0" smtClean="0"/>
-              <a:t>상용 </a:t>
-            </a:r>
-            <a:r>
               <a:rPr lang="ko-KR" altLang="en-US" sz="1100" dirty="0"/>
-              <a:t>코드베이스의 비율</a:t>
+              <a:t>상용 코드베이스의 비율</a:t>
             </a:r>
             <a:endParaRPr lang="en-US" sz="1100" dirty="0"/>
           </a:p>
@@ -13645,6 +14228,13 @@
           </a:solidFill>
           <a:ln/>
         </p:spPr>
+        <p:txBody>
+          <a:bodyPr/>
+          <a:lstStyle/>
+          <a:p>
+            <a:endParaRPr lang="ko-KR" altLang="en-US"/>
+          </a:p>
+        </p:txBody>
       </p:sp>
       <p:sp>
         <p:nvSpPr>
@@ -13745,14 +14335,6 @@
               </a:rPr>
               <a:t> </a:t>
             </a:r>
-            <a:endParaRPr lang="en-US" sz="1100" dirty="0" smtClean="0">
-              <a:solidFill>
-                <a:srgbClr val="1C1633"/>
-              </a:solidFill>
-              <a:latin typeface="맑은 고딕" pitchFamily="34" charset="0"/>
-              <a:ea typeface="맑은 고딕" pitchFamily="34" charset="-122"/>
-              <a:cs typeface="맑은 고딕" pitchFamily="34" charset="-120"/>
-            </a:endParaRPr>
           </a:p>
           <a:p>
             <a:pPr marL="0" indent="0">
@@ -13762,7 +14344,7 @@
               <a:buNone/>
             </a:pPr>
             <a:r>
-              <a:rPr lang="en-US" sz="1100" dirty="0" smtClean="0">
+              <a:rPr lang="en-US" sz="1100" dirty="0">
                 <a:solidFill>
                   <a:srgbClr val="1C1633"/>
                 </a:solidFill>
@@ -13770,18 +14352,7 @@
                 <a:ea typeface="맑은 고딕" pitchFamily="34" charset="-122"/>
                 <a:cs typeface="맑은 고딕" pitchFamily="34" charset="-120"/>
               </a:rPr>
-              <a:t>— </a:t>
-            </a:r>
-            <a:r>
-              <a:rPr lang="en-US" sz="1100" dirty="0">
-                <a:solidFill>
-                  <a:srgbClr val="1C1633"/>
-                </a:solidFill>
-                <a:latin typeface="맑은 고딕" pitchFamily="34" charset="0"/>
-                <a:ea typeface="맑은 고딕" pitchFamily="34" charset="-122"/>
-                <a:cs typeface="맑은 고딕" pitchFamily="34" charset="-120"/>
-              </a:rPr>
-              <a:t>과거 40%대에서 지속 하락</a:t>
+              <a:t>— 과거 40%대에서 지속 하락</a:t>
             </a:r>
             <a:endParaRPr lang="en-US" sz="1100" dirty="0"/>
           </a:p>
@@ -13808,6 +14379,13 @@
           </a:solidFill>
           <a:ln/>
         </p:spPr>
+        <p:txBody>
+          <a:bodyPr/>
+          <a:lstStyle/>
+          <a:p>
+            <a:endParaRPr lang="ko-KR" altLang="en-US"/>
+          </a:p>
+        </p:txBody>
       </p:sp>
       <p:sp>
         <p:nvSpPr>
@@ -13919,14 +14497,6 @@
               </a:rPr>
               <a:t>은 Kubernetes 등 클라우드 네이티브 진영에서 강세입니다. </a:t>
             </a:r>
-            <a:endParaRPr lang="en-US" sz="1200" dirty="0" smtClean="0">
-              <a:solidFill>
-                <a:srgbClr val="D9D3EE"/>
-              </a:solidFill>
-              <a:latin typeface="맑은 고딕" pitchFamily="34" charset="0"/>
-              <a:ea typeface="맑은 고딕" pitchFamily="34" charset="-122"/>
-              <a:cs typeface="맑은 고딕" pitchFamily="34" charset="-120"/>
-            </a:endParaRPr>
           </a:p>
           <a:p>
             <a:pPr marL="0" indent="0">
@@ -13936,7 +14506,7 @@
               <a:buNone/>
             </a:pPr>
             <a:r>
-              <a:rPr lang="en-US" sz="1200" dirty="0" smtClean="0">
+              <a:rPr lang="en-US" sz="1200" dirty="0">
                 <a:solidFill>
                   <a:srgbClr val="D9D3EE"/>
                 </a:solidFill>
@@ -13944,18 +14514,7 @@
                 <a:ea typeface="맑은 고딕" pitchFamily="34" charset="-122"/>
                 <a:cs typeface="맑은 고딕" pitchFamily="34" charset="-120"/>
               </a:rPr>
-              <a:t>GPL </a:t>
-            </a:r>
-            <a:r>
-              <a:rPr lang="en-US" sz="1200" dirty="0">
-                <a:solidFill>
-                  <a:srgbClr val="D9D3EE"/>
-                </a:solidFill>
-                <a:latin typeface="맑은 고딕" pitchFamily="34" charset="0"/>
-                <a:ea typeface="맑은 고딕" pitchFamily="34" charset="-122"/>
-                <a:cs typeface="맑은 고딕" pitchFamily="34" charset="-120"/>
-              </a:rPr>
-              <a:t>계열은 Linux 커널 등 시스템 소프트웨어에 집중되며 비중이 꾸준히 줄고 있습니다.</a:t>
+              <a:t>GPL 계열은 Linux 커널 등 시스템 소프트웨어에 집중되며 비중이 꾸준히 줄고 있습니다.</a:t>
             </a:r>
             <a:endParaRPr lang="en-US" sz="1200" dirty="0"/>
           </a:p>
@@ -14132,6 +14691,13 @@
           </a:solidFill>
           <a:ln/>
         </p:spPr>
+        <p:txBody>
+          <a:bodyPr/>
+          <a:lstStyle/>
+          <a:p>
+            <a:endParaRPr lang="ko-KR" altLang="en-US"/>
+          </a:p>
+        </p:txBody>
       </p:sp>
       <p:sp>
         <p:nvSpPr>
@@ -14271,6 +14837,13 @@
           </a:solidFill>
           <a:ln/>
         </p:spPr>
+        <p:txBody>
+          <a:bodyPr/>
+          <a:lstStyle/>
+          <a:p>
+            <a:endParaRPr lang="ko-KR" altLang="en-US"/>
+          </a:p>
+        </p:txBody>
       </p:sp>
       <p:sp>
         <p:nvSpPr>
@@ -14372,7 +14945,7 @@
               <a:t> </a:t>
             </a:r>
             <a:r>
-              <a:rPr lang="en-US" sz="1050" dirty="0" err="1" smtClean="0">
+              <a:rPr lang="en-US" sz="1050" dirty="0" err="1">
                 <a:solidFill>
                   <a:srgbClr val="1C1633"/>
                 </a:solidFill>
@@ -14407,6 +14980,13 @@
           </a:solidFill>
           <a:ln/>
         </p:spPr>
+        <p:txBody>
+          <a:bodyPr/>
+          <a:lstStyle/>
+          <a:p>
+            <a:endParaRPr lang="ko-KR" altLang="en-US"/>
+          </a:p>
+        </p:txBody>
       </p:sp>
       <p:sp>
         <p:nvSpPr>
@@ -14508,7 +15088,7 @@
               <a:t> </a:t>
             </a:r>
             <a:r>
-              <a:rPr lang="en-US" sz="1050" dirty="0" err="1" smtClean="0">
+              <a:rPr lang="en-US" sz="1050" dirty="0" err="1">
                 <a:solidFill>
                   <a:srgbClr val="1C1633"/>
                 </a:solidFill>
@@ -14519,7 +15099,7 @@
               <a:t>Risk를</a:t>
             </a:r>
             <a:r>
-              <a:rPr lang="en-US" sz="1050" dirty="0" smtClean="0">
+              <a:rPr lang="en-US" sz="1050" dirty="0">
                 <a:solidFill>
                   <a:srgbClr val="1C1633"/>
                 </a:solidFill>
@@ -14527,18 +15107,7 @@
                 <a:ea typeface="맑은 고딕" pitchFamily="34" charset="-122"/>
                 <a:cs typeface="맑은 고딕" pitchFamily="34" charset="-120"/>
               </a:rPr>
-              <a:t> </a:t>
-            </a:r>
-            <a:r>
-              <a:rPr lang="en-US" sz="1050" dirty="0">
-                <a:solidFill>
-                  <a:srgbClr val="1C1633"/>
-                </a:solidFill>
-                <a:latin typeface="맑은 고딕" pitchFamily="34" charset="0"/>
-                <a:ea typeface="맑은 고딕" pitchFamily="34" charset="-122"/>
-                <a:cs typeface="맑은 고딕" pitchFamily="34" charset="-120"/>
-              </a:rPr>
-              <a:t>검토하는 기업 비율 — 나머지 절반 가까이는 검토 없이 사용</a:t>
+              <a:t> 검토하는 기업 비율 — 나머지 절반 가까이는 검토 없이 사용</a:t>
             </a:r>
             <a:endParaRPr lang="en-US" sz="1050" dirty="0"/>
           </a:p>
@@ -14565,6 +15134,13 @@
           </a:solidFill>
           <a:ln/>
         </p:spPr>
+        <p:txBody>
+          <a:bodyPr/>
+          <a:lstStyle/>
+          <a:p>
+            <a:endParaRPr lang="ko-KR" altLang="en-US"/>
+          </a:p>
+        </p:txBody>
       </p:sp>
       <p:sp>
         <p:nvSpPr>
@@ -14668,6 +15244,13 @@
           </a:solidFill>
           <a:ln/>
         </p:spPr>
+        <p:txBody>
+          <a:bodyPr/>
+          <a:lstStyle/>
+          <a:p>
+            <a:endParaRPr lang="ko-KR" altLang="en-US"/>
+          </a:p>
+        </p:txBody>
       </p:sp>
       <p:sp>
         <p:nvSpPr>
@@ -14932,6 +15515,13 @@
           </a:solidFill>
           <a:ln/>
         </p:spPr>
+        <p:txBody>
+          <a:bodyPr/>
+          <a:lstStyle/>
+          <a:p>
+            <a:endParaRPr lang="ko-KR" altLang="en-US"/>
+          </a:p>
+        </p:txBody>
       </p:sp>
       <p:sp>
         <p:nvSpPr>
@@ -15071,6 +15661,13 @@
           </a:solidFill>
           <a:ln/>
         </p:spPr>
+        <p:txBody>
+          <a:bodyPr/>
+          <a:lstStyle/>
+          <a:p>
+            <a:endParaRPr lang="ko-KR" altLang="en-US"/>
+          </a:p>
+        </p:txBody>
       </p:sp>
       <p:sp>
         <p:nvSpPr>
@@ -15091,6 +15688,13 @@
           </a:solidFill>
           <a:ln/>
         </p:spPr>
+        <p:txBody>
+          <a:bodyPr/>
+          <a:lstStyle/>
+          <a:p>
+            <a:endParaRPr lang="ko-KR" altLang="en-US"/>
+          </a:p>
+        </p:txBody>
       </p:sp>
       <p:sp>
         <p:nvSpPr>
@@ -15236,6 +15840,13 @@
           </a:solidFill>
           <a:ln/>
         </p:spPr>
+        <p:txBody>
+          <a:bodyPr/>
+          <a:lstStyle/>
+          <a:p>
+            <a:endParaRPr lang="ko-KR" altLang="en-US"/>
+          </a:p>
+        </p:txBody>
       </p:sp>
       <p:sp>
         <p:nvSpPr>
@@ -15256,6 +15867,13 @@
           </a:solidFill>
           <a:ln/>
         </p:spPr>
+        <p:txBody>
+          <a:bodyPr/>
+          <a:lstStyle/>
+          <a:p>
+            <a:endParaRPr lang="ko-KR" altLang="en-US"/>
+          </a:p>
+        </p:txBody>
       </p:sp>
       <p:sp>
         <p:nvSpPr>
@@ -15401,6 +16019,13 @@
           </a:solidFill>
           <a:ln/>
         </p:spPr>
+        <p:txBody>
+          <a:bodyPr/>
+          <a:lstStyle/>
+          <a:p>
+            <a:endParaRPr lang="ko-KR" altLang="en-US"/>
+          </a:p>
+        </p:txBody>
       </p:sp>
       <p:sp>
         <p:nvSpPr>
@@ -15421,6 +16046,13 @@
           </a:solidFill>
           <a:ln/>
         </p:spPr>
+        <p:txBody>
+          <a:bodyPr/>
+          <a:lstStyle/>
+          <a:p>
+            <a:endParaRPr lang="ko-KR" altLang="en-US"/>
+          </a:p>
+        </p:txBody>
       </p:sp>
       <p:sp>
         <p:nvSpPr>
@@ -15677,6 +16309,13 @@
           </a:solidFill>
           <a:ln/>
         </p:spPr>
+        <p:txBody>
+          <a:bodyPr/>
+          <a:lstStyle/>
+          <a:p>
+            <a:endParaRPr lang="ko-KR" altLang="en-US"/>
+          </a:p>
+        </p:txBody>
       </p:sp>
       <p:sp>
         <p:nvSpPr>
@@ -15816,6 +16455,13 @@
           </a:solidFill>
           <a:ln/>
         </p:spPr>
+        <p:txBody>
+          <a:bodyPr/>
+          <a:lstStyle/>
+          <a:p>
+            <a:endParaRPr lang="ko-KR" altLang="en-US"/>
+          </a:p>
+        </p:txBody>
       </p:sp>
       <p:sp>
         <p:nvSpPr>
@@ -15920,6 +16566,13 @@
             <a:prstDash val="solid"/>
           </a:ln>
         </p:spPr>
+        <p:txBody>
+          <a:bodyPr/>
+          <a:lstStyle/>
+          <a:p>
+            <a:endParaRPr lang="ko-KR" altLang="en-US"/>
+          </a:p>
+        </p:txBody>
       </p:sp>
       <p:sp>
         <p:nvSpPr>
@@ -16051,29 +16704,7 @@
                 <a:ea typeface="맑은 고딕" pitchFamily="34" charset="-122"/>
                 <a:cs typeface="맑은 고딕" pitchFamily="34" charset="-120"/>
               </a:rPr>
-              <a:t>코드에 </a:t>
-            </a:r>
-            <a:r>
-              <a:rPr lang="ko-KR" altLang="en-US" sz="1000" dirty="0" smtClean="0">
-                <a:solidFill>
-                  <a:srgbClr val="6E6690"/>
-                </a:solidFill>
-                <a:latin typeface="맑은 고딕" pitchFamily="34" charset="0"/>
-                <a:ea typeface="맑은 고딕" pitchFamily="34" charset="-122"/>
-                <a:cs typeface="맑은 고딕" pitchFamily="34" charset="-120"/>
-              </a:rPr>
-              <a:t>저작권 </a:t>
-            </a:r>
-            <a:r>
-              <a:rPr lang="ko-KR" altLang="en-US" sz="1000" dirty="0">
-                <a:solidFill>
-                  <a:srgbClr val="6E6690"/>
-                </a:solidFill>
-                <a:latin typeface="맑은 고딕" pitchFamily="34" charset="0"/>
-                <a:ea typeface="맑은 고딕" pitchFamily="34" charset="-122"/>
-                <a:cs typeface="맑은 고딕" pitchFamily="34" charset="-120"/>
-              </a:rPr>
-              <a:t>문구 유지로 충분한 경우가 많음</a:t>
+              <a:t>코드에 저작권 문구 유지로 충분한 경우가 많음</a:t>
             </a:r>
           </a:p>
         </p:txBody>
@@ -16099,6 +16730,13 @@
           </a:solidFill>
           <a:ln/>
         </p:spPr>
+        <p:txBody>
+          <a:bodyPr/>
+          <a:lstStyle/>
+          <a:p>
+            <a:endParaRPr lang="ko-KR" altLang="en-US"/>
+          </a:p>
+        </p:txBody>
       </p:sp>
       <p:sp>
         <p:nvSpPr>
@@ -16203,6 +16841,13 @@
             <a:prstDash val="solid"/>
           </a:ln>
         </p:spPr>
+        <p:txBody>
+          <a:bodyPr/>
+          <a:lstStyle/>
+          <a:p>
+            <a:endParaRPr lang="ko-KR" altLang="en-US"/>
+          </a:p>
+        </p:txBody>
       </p:sp>
       <p:sp>
         <p:nvSpPr>
@@ -16309,6 +16954,13 @@
           </a:solidFill>
           <a:ln/>
         </p:spPr>
+        <p:txBody>
+          <a:bodyPr/>
+          <a:lstStyle/>
+          <a:p>
+            <a:endParaRPr lang="ko-KR" altLang="en-US"/>
+          </a:p>
+        </p:txBody>
       </p:sp>
       <p:sp>
         <p:nvSpPr>
@@ -16413,6 +17065,13 @@
             <a:prstDash val="solid"/>
           </a:ln>
         </p:spPr>
+        <p:txBody>
+          <a:bodyPr/>
+          <a:lstStyle/>
+          <a:p>
+            <a:endParaRPr lang="ko-KR" altLang="en-US"/>
+          </a:p>
+        </p:txBody>
       </p:sp>
       <p:sp>
         <p:nvSpPr>
@@ -16449,10 +17108,10 @@
                 <a:ea typeface="맑은 고딕" pitchFamily="34" charset="-122"/>
                 <a:cs typeface="맑은 고딕" pitchFamily="34" charset="-120"/>
               </a:rPr>
-              <a:t>Patent Retaliation </a:t>
-            </a:r>
-            <a:r>
-              <a:rPr lang="en-US" sz="1000" b="1" dirty="0" smtClean="0">
+              <a:t>Patent Retaliation —</a:t>
+            </a:r>
+            <a:r>
+              <a:rPr lang="ko-KR" altLang="en-US" sz="1000" b="1" dirty="0">
                 <a:solidFill>
                   <a:srgbClr val="4C2FB0"/>
                 </a:solidFill>
@@ -16460,29 +17119,7 @@
                 <a:ea typeface="맑은 고딕" pitchFamily="34" charset="-122"/>
                 <a:cs typeface="맑은 고딕" pitchFamily="34" charset="-120"/>
               </a:rPr>
-              <a:t>—</a:t>
-            </a:r>
-            <a:r>
-              <a:rPr lang="ko-KR" altLang="en-US" sz="1000" b="1" dirty="0" smtClean="0">
-                <a:solidFill>
-                  <a:srgbClr val="4C2FB0"/>
-                </a:solidFill>
-                <a:latin typeface="맑은 고딕" pitchFamily="34" charset="0"/>
-                <a:ea typeface="맑은 고딕" pitchFamily="34" charset="-122"/>
-                <a:cs typeface="맑은 고딕" pitchFamily="34" charset="-120"/>
-              </a:rPr>
-              <a:t>사용자가 </a:t>
-            </a:r>
-            <a:r>
-              <a:rPr lang="ko-KR" altLang="en-US" sz="1000" b="1" dirty="0">
-                <a:solidFill>
-                  <a:srgbClr val="4C2FB0"/>
-                </a:solidFill>
-                <a:latin typeface="맑은 고딕" pitchFamily="34" charset="0"/>
-                <a:ea typeface="맑은 고딕" pitchFamily="34" charset="-122"/>
-                <a:cs typeface="맑은 고딕" pitchFamily="34" charset="-120"/>
-              </a:rPr>
-              <a:t>특허소송을 걸면 라이선스가 자동 종료되고 로열티가 부과되는 등 보복 조항이 적용됩니다</a:t>
+              <a:t>사용자가 특허소송을 걸면 라이선스가 자동 종료되고 로열티가 부과되는 등 보복 조항이 적용됩니다</a:t>
             </a:r>
             <a:r>
               <a:rPr lang="en-US" altLang="ko-KR" sz="1000" b="1" dirty="0">
@@ -16639,6 +17276,13 @@
           </a:solidFill>
           <a:ln/>
         </p:spPr>
+        <p:txBody>
+          <a:bodyPr/>
+          <a:lstStyle/>
+          <a:p>
+            <a:endParaRPr lang="ko-KR" altLang="en-US"/>
+          </a:p>
+        </p:txBody>
       </p:sp>
       <p:sp>
         <p:nvSpPr>
@@ -16778,6 +17422,13 @@
           </a:solidFill>
           <a:ln/>
         </p:spPr>
+        <p:txBody>
+          <a:bodyPr/>
+          <a:lstStyle/>
+          <a:p>
+            <a:endParaRPr lang="ko-KR" altLang="en-US"/>
+          </a:p>
+        </p:txBody>
       </p:sp>
       <p:sp>
         <p:nvSpPr>
@@ -16798,6 +17449,13 @@
           </a:solidFill>
           <a:ln/>
         </p:spPr>
+        <p:txBody>
+          <a:bodyPr/>
+          <a:lstStyle/>
+          <a:p>
+            <a:endParaRPr lang="ko-KR" altLang="en-US"/>
+          </a:p>
+        </p:txBody>
       </p:sp>
       <p:sp>
         <p:nvSpPr>
@@ -16820,6 +17478,13 @@
           </a:solidFill>
           <a:ln/>
         </p:spPr>
+        <p:txBody>
+          <a:bodyPr/>
+          <a:lstStyle/>
+          <a:p>
+            <a:endParaRPr lang="ko-KR" altLang="en-US"/>
+          </a:p>
+        </p:txBody>
       </p:sp>
       <p:sp>
         <p:nvSpPr>
@@ -16920,6 +17585,13 @@
           </a:solidFill>
           <a:ln/>
         </p:spPr>
+        <p:txBody>
+          <a:bodyPr/>
+          <a:lstStyle/>
+          <a:p>
+            <a:endParaRPr lang="ko-KR" altLang="en-US"/>
+          </a:p>
+        </p:txBody>
       </p:sp>
       <p:sp>
         <p:nvSpPr>
@@ -17076,14 +17748,6 @@
               </a:rPr>
               <a:t>수정해도 소스공개 의무 없음. </a:t>
             </a:r>
-            <a:endParaRPr lang="en-US" sz="1050" dirty="0" smtClean="0">
-              <a:solidFill>
-                <a:srgbClr val="1C1633"/>
-              </a:solidFill>
-              <a:latin typeface="맑은 고딕" pitchFamily="34" charset="0"/>
-              <a:ea typeface="맑은 고딕" pitchFamily="34" charset="-122"/>
-              <a:cs typeface="맑은 고딕" pitchFamily="34" charset="-120"/>
-            </a:endParaRPr>
           </a:p>
           <a:p>
             <a:pPr marL="0" indent="0">
@@ -17093,7 +17757,7 @@
               <a:buNone/>
             </a:pPr>
             <a:r>
-              <a:rPr lang="en-US" sz="1050" dirty="0" err="1" smtClean="0">
+              <a:rPr lang="en-US" sz="1050" dirty="0" err="1">
                 <a:solidFill>
                   <a:srgbClr val="1C1633"/>
                 </a:solidFill>
@@ -17104,7 +17768,7 @@
               <a:t>저작권</a:t>
             </a:r>
             <a:r>
-              <a:rPr lang="en-US" sz="1050" dirty="0" smtClean="0">
+              <a:rPr lang="en-US" sz="1050" dirty="0">
                 <a:solidFill>
                   <a:srgbClr val="1C1633"/>
                 </a:solidFill>
@@ -17112,18 +17776,7 @@
                 <a:ea typeface="맑은 고딕" pitchFamily="34" charset="-122"/>
                 <a:cs typeface="맑은 고딕" pitchFamily="34" charset="-120"/>
               </a:rPr>
-              <a:t> </a:t>
-            </a:r>
-            <a:r>
-              <a:rPr lang="en-US" sz="1050" dirty="0">
-                <a:solidFill>
-                  <a:srgbClr val="1C1633"/>
-                </a:solidFill>
-                <a:latin typeface="맑은 고딕" pitchFamily="34" charset="0"/>
-                <a:ea typeface="맑은 고딕" pitchFamily="34" charset="-122"/>
-                <a:cs typeface="맑은 고딕" pitchFamily="34" charset="-120"/>
-              </a:rPr>
-              <a:t>표시만 유지하면 자유롭게 사용</a:t>
+              <a:t> 표시만 유지하면 자유롭게 사용</a:t>
             </a:r>
             <a:endParaRPr lang="en-US" sz="1050" dirty="0"/>
           </a:p>
@@ -17150,6 +17803,13 @@
           </a:solidFill>
           <a:ln/>
         </p:spPr>
+        <p:txBody>
+          <a:bodyPr/>
+          <a:lstStyle/>
+          <a:p>
+            <a:endParaRPr lang="ko-KR" altLang="en-US"/>
+          </a:p>
+        </p:txBody>
       </p:sp>
       <p:sp>
         <p:nvSpPr>
@@ -17306,14 +17966,6 @@
               </a:rPr>
               <a:t>수정한 부분만 공개 의무. </a:t>
             </a:r>
-            <a:endParaRPr lang="en-US" sz="1050" dirty="0" smtClean="0">
-              <a:solidFill>
-                <a:srgbClr val="1C1633"/>
-              </a:solidFill>
-              <a:latin typeface="맑은 고딕" pitchFamily="34" charset="0"/>
-              <a:ea typeface="맑은 고딕" pitchFamily="34" charset="-122"/>
-              <a:cs typeface="맑은 고딕" pitchFamily="34" charset="-120"/>
-            </a:endParaRPr>
           </a:p>
           <a:p>
             <a:pPr marL="0" indent="0">
@@ -17323,7 +17975,7 @@
               <a:buNone/>
             </a:pPr>
             <a:r>
-              <a:rPr lang="en-US" sz="1050" dirty="0" err="1" smtClean="0">
+              <a:rPr lang="en-US" sz="1050" dirty="0" err="1">
                 <a:solidFill>
                   <a:srgbClr val="1C1633"/>
                 </a:solidFill>
@@ -17331,18 +17983,7 @@
                 <a:ea typeface="맑은 고딕" pitchFamily="34" charset="-122"/>
                 <a:cs typeface="맑은 고딕" pitchFamily="34" charset="-120"/>
               </a:rPr>
-              <a:t>연결</a:t>
-            </a:r>
-            <a:r>
-              <a:rPr lang="en-US" sz="1050" dirty="0" err="1">
-                <a:solidFill>
-                  <a:srgbClr val="1C1633"/>
-                </a:solidFill>
-                <a:latin typeface="맑은 고딕" pitchFamily="34" charset="0"/>
-                <a:ea typeface="맑은 고딕" pitchFamily="34" charset="-122"/>
-                <a:cs typeface="맑은 고딕" pitchFamily="34" charset="-120"/>
-              </a:rPr>
-              <a:t>·결합된</a:t>
+              <a:t>연결·결합된</a:t>
             </a:r>
             <a:r>
               <a:rPr lang="en-US" sz="1050" dirty="0">
@@ -17380,6 +18021,13 @@
           </a:solidFill>
           <a:ln/>
         </p:spPr>
+        <p:txBody>
+          <a:bodyPr/>
+          <a:lstStyle/>
+          <a:p>
+            <a:endParaRPr lang="ko-KR" altLang="en-US"/>
+          </a:p>
+        </p:txBody>
       </p:sp>
       <p:sp>
         <p:nvSpPr>
@@ -17589,14 +18237,6 @@
               </a:rPr>
               <a:t>는 저작물을 보호하고 사용자가 저작자의 허락을 받도록 하는 개념이고, </a:t>
             </a:r>
-            <a:endParaRPr lang="en-US" sz="1100" dirty="0" smtClean="0">
-              <a:solidFill>
-                <a:srgbClr val="1C1633"/>
-              </a:solidFill>
-              <a:latin typeface="맑은 고딕" pitchFamily="34" charset="0"/>
-              <a:ea typeface="맑은 고딕" pitchFamily="34" charset="-122"/>
-              <a:cs typeface="맑은 고딕" pitchFamily="34" charset="-120"/>
-            </a:endParaRPr>
           </a:p>
           <a:p>
             <a:pPr marL="0" indent="0">
@@ -17606,7 +18246,7 @@
               <a:buNone/>
             </a:pPr>
             <a:r>
-              <a:rPr lang="en-US" sz="1100" b="1" dirty="0" err="1" smtClean="0">
+              <a:rPr lang="en-US" sz="1100" b="1" dirty="0" err="1">
                 <a:solidFill>
                   <a:srgbClr val="0E9A57"/>
                 </a:solidFill>
@@ -17661,7 +18301,7 @@
               <a:t> </a:t>
             </a:r>
             <a:r>
-              <a:rPr lang="ko-KR" altLang="en-US" sz="1100" dirty="0" smtClean="0">
+              <a:rPr lang="ko-KR" altLang="en-US" sz="1100" dirty="0">
                 <a:solidFill>
                   <a:srgbClr val="1C1633"/>
                 </a:solidFill>
@@ -17672,7 +18312,7 @@
               <a:t>함으로써</a:t>
             </a:r>
             <a:r>
-              <a:rPr lang="en-US" sz="1100" dirty="0" smtClean="0">
+              <a:rPr lang="en-US" sz="1100" dirty="0">
                 <a:solidFill>
                   <a:srgbClr val="1C1633"/>
                 </a:solidFill>
@@ -17680,18 +18320,7 @@
                 <a:ea typeface="맑은 고딕" pitchFamily="34" charset="-122"/>
                 <a:cs typeface="맑은 고딕" pitchFamily="34" charset="-120"/>
               </a:rPr>
-              <a:t> </a:t>
-            </a:r>
-            <a:r>
-              <a:rPr lang="en-US" sz="1100" dirty="0">
-                <a:solidFill>
-                  <a:srgbClr val="1C1633"/>
-                </a:solidFill>
-                <a:latin typeface="맑은 고딕" pitchFamily="34" charset="0"/>
-                <a:ea typeface="맑은 고딕" pitchFamily="34" charset="-122"/>
-                <a:cs typeface="맑은 고딕" pitchFamily="34" charset="-120"/>
-              </a:rPr>
-              <a:t>파생물이 계속 자유롭게 유지되도록 합니다.</a:t>
+              <a:t> 파생물이 계속 자유롭게 유지되도록 합니다.</a:t>
             </a:r>
             <a:endParaRPr lang="en-US" sz="1100" dirty="0"/>
           </a:p>
@@ -17829,6 +18458,13 @@
           </a:solidFill>
           <a:ln/>
         </p:spPr>
+        <p:txBody>
+          <a:bodyPr/>
+          <a:lstStyle/>
+          <a:p>
+            <a:endParaRPr lang="ko-KR" altLang="en-US"/>
+          </a:p>
+        </p:txBody>
       </p:sp>
       <p:sp>
         <p:nvSpPr>
@@ -17968,6 +18604,13 @@
           </a:solidFill>
           <a:ln/>
         </p:spPr>
+        <p:txBody>
+          <a:bodyPr/>
+          <a:lstStyle/>
+          <a:p>
+            <a:endParaRPr lang="ko-KR" altLang="en-US"/>
+          </a:p>
+        </p:txBody>
       </p:sp>
       <p:sp>
         <p:nvSpPr>
@@ -18199,6 +18842,13 @@
           </a:solidFill>
           <a:ln/>
         </p:spPr>
+        <p:txBody>
+          <a:bodyPr/>
+          <a:lstStyle/>
+          <a:p>
+            <a:endParaRPr lang="ko-KR" altLang="en-US"/>
+          </a:p>
+        </p:txBody>
       </p:sp>
       <p:sp>
         <p:nvSpPr>
@@ -18260,6 +18910,13 @@
           </a:solidFill>
           <a:ln/>
         </p:spPr>
+        <p:txBody>
+          <a:bodyPr/>
+          <a:lstStyle/>
+          <a:p>
+            <a:endParaRPr lang="ko-KR" altLang="en-US"/>
+          </a:p>
+        </p:txBody>
       </p:sp>
       <p:sp>
         <p:nvSpPr>
@@ -18382,7 +19039,7 @@
               <a:t> 걸어 수정판 실행을 막는 걸 금지</a:t>
             </a:r>
             <a:r>
-              <a:rPr lang="en-US" altLang="ko-KR" sz="1100" dirty="0" smtClean="0"/>
+              <a:rPr lang="en-US" altLang="ko-KR" sz="1100" dirty="0"/>
               <a:t>)</a:t>
             </a:r>
             <a:endParaRPr lang="en-US" sz="1100" dirty="0"/>
@@ -18494,6 +19151,13 @@
           </a:solidFill>
           <a:ln/>
         </p:spPr>
+        <p:txBody>
+          <a:bodyPr/>
+          <a:lstStyle/>
+          <a:p>
+            <a:endParaRPr lang="ko-KR" altLang="en-US"/>
+          </a:p>
+        </p:txBody>
       </p:sp>
       <p:sp>
         <p:nvSpPr>

</xml_diff>